<commit_message>
Research review: merge second search pass (closest single-link prior art, 8 more verified sources); update deck slide 4, references and prep guide
Co-authored-by: Harshvardhan Choudhary <Harshvardhan-To1@users.noreply.github.com>
</commit_message>
<xml_diff>
--- a/docs/mid_evaluation.pptx
+++ b/docs/mid_evaluation.pptx
@@ -1681,7 +1681,12 @@
           </a:p>
           <a:p>
             <a:r>
-              <a:t>Row six: the numerical foundations — HMT for the randomised range finder and its bound, Shoham–Gersho for the allocation algorithm. I claim no novelty in these algorithms.</a:t>
+              <a:t>Row six is the closest prior art, found in a second search pass: Aswathylakshmi and Ganti compress a 64-antenna TDL-A uplink through the same delay-domain low rank as CSEE, but they first separate the data symbols by blind deconvolution — which is precisely why my CSEE without that step needs reference symbols. Li et al. adapt the bit-width to load and SINR on a single eCPRI link; Kanno et al. allocate bits per SVD stream at one access point. My allocator generalises that to several RUs sharing one link with heterogeneous operating points.</a:t>
+            </a:r>
+          </a:p>
+          <a:p>
+            <a:r>
+              <a:t>Row seven: the numerical foundations — HMT for the randomised range finder and its bound, Shoham–Gersho for the allocation algorithm. I claim no novelty in these algorithms.</a:t>
             </a:r>
           </a:p>
         </p:txBody>
@@ -8851,11 +8856,11 @@
                 <a:spcPct val="105000"/>
               </a:lnSpc>
               <a:spcAft>
-                <a:spcPts val="300"/>
-              </a:spcAft>
-            </a:pPr>
-            <a:r>
-              <a:rPr sz="1100" b="0">
+                <a:spcPts val="200"/>
+              </a:spcAft>
+            </a:pPr>
+            <a:r>
+              <a:rPr sz="1000" b="0">
                 <a:solidFill>
                   <a:srgbClr val="1B1B1B"/>
                 </a:solidFill>
@@ -8870,11 +8875,11 @@
                 <a:spcPct val="105000"/>
               </a:lnSpc>
               <a:spcAft>
-                <a:spcPts val="300"/>
-              </a:spcAft>
-            </a:pPr>
-            <a:r>
-              <a:rPr sz="1100" b="0">
+                <a:spcPts val="200"/>
+              </a:spcAft>
+            </a:pPr>
+            <a:r>
+              <a:rPr sz="1000" b="0">
                 <a:solidFill>
                   <a:srgbClr val="1B1B1B"/>
                 </a:solidFill>
@@ -8889,11 +8894,11 @@
                 <a:spcPct val="105000"/>
               </a:lnSpc>
               <a:spcAft>
-                <a:spcPts val="300"/>
-              </a:spcAft>
-            </a:pPr>
-            <a:r>
-              <a:rPr sz="1100" b="0">
+                <a:spcPts val="200"/>
+              </a:spcAft>
+            </a:pPr>
+            <a:r>
+              <a:rPr sz="1000" b="0">
                 <a:solidFill>
                   <a:srgbClr val="1B1B1B"/>
                 </a:solidFill>
@@ -8908,11 +8913,11 @@
                 <a:spcPct val="105000"/>
               </a:lnSpc>
               <a:spcAft>
-                <a:spcPts val="300"/>
-              </a:spcAft>
-            </a:pPr>
-            <a:r>
-              <a:rPr sz="1100" b="0">
+                <a:spcPts val="200"/>
+              </a:spcAft>
+            </a:pPr>
+            <a:r>
+              <a:rPr sz="1000" b="0">
                 <a:solidFill>
                   <a:srgbClr val="1B1B1B"/>
                 </a:solidFill>
@@ -8927,11 +8932,11 @@
                 <a:spcPct val="105000"/>
               </a:lnSpc>
               <a:spcAft>
-                <a:spcPts val="300"/>
-              </a:spcAft>
-            </a:pPr>
-            <a:r>
-              <a:rPr sz="1100" b="0">
+                <a:spcPts val="200"/>
+              </a:spcAft>
+            </a:pPr>
+            <a:r>
+              <a:rPr sz="1000" b="0">
                 <a:solidFill>
                   <a:srgbClr val="1B1B1B"/>
                 </a:solidFill>
@@ -8946,11 +8951,11 @@
                 <a:spcPct val="105000"/>
               </a:lnSpc>
               <a:spcAft>
-                <a:spcPts val="300"/>
-              </a:spcAft>
-            </a:pPr>
-            <a:r>
-              <a:rPr sz="1100" b="0">
+                <a:spcPts val="200"/>
+              </a:spcAft>
+            </a:pPr>
+            <a:r>
+              <a:rPr sz="1000" b="0">
                 <a:solidFill>
                   <a:srgbClr val="1B1B1B"/>
                 </a:solidFill>
@@ -8965,11 +8970,11 @@
                 <a:spcPct val="105000"/>
               </a:lnSpc>
               <a:spcAft>
-                <a:spcPts val="300"/>
-              </a:spcAft>
-            </a:pPr>
-            <a:r>
-              <a:rPr sz="1100" b="0">
+                <a:spcPts val="200"/>
+              </a:spcAft>
+            </a:pPr>
+            <a:r>
+              <a:rPr sz="1000" b="0">
                 <a:solidFill>
                   <a:srgbClr val="1B1B1B"/>
                 </a:solidFill>
@@ -8984,11 +8989,11 @@
                 <a:spcPct val="105000"/>
               </a:lnSpc>
               <a:spcAft>
-                <a:spcPts val="300"/>
-              </a:spcAft>
-            </a:pPr>
-            <a:r>
-              <a:rPr sz="1100" b="0">
+                <a:spcPts val="200"/>
+              </a:spcAft>
+            </a:pPr>
+            <a:r>
+              <a:rPr sz="1000" b="0">
                 <a:solidFill>
                   <a:srgbClr val="1B1B1B"/>
                 </a:solidFill>
@@ -9003,11 +9008,11 @@
                 <a:spcPct val="105000"/>
               </a:lnSpc>
               <a:spcAft>
-                <a:spcPts val="300"/>
-              </a:spcAft>
-            </a:pPr>
-            <a:r>
-              <a:rPr sz="1100" b="0">
+                <a:spcPts val="200"/>
+              </a:spcAft>
+            </a:pPr>
+            <a:r>
+              <a:rPr sz="1000" b="0">
                 <a:solidFill>
                   <a:srgbClr val="1B1B1B"/>
                 </a:solidFill>
@@ -9022,11 +9027,11 @@
                 <a:spcPct val="105000"/>
               </a:lnSpc>
               <a:spcAft>
-                <a:spcPts val="300"/>
-              </a:spcAft>
-            </a:pPr>
-            <a:r>
-              <a:rPr sz="1100" b="0">
+                <a:spcPts val="200"/>
+              </a:spcAft>
+            </a:pPr>
+            <a:r>
+              <a:rPr sz="1000" b="0">
                 <a:solidFill>
                   <a:srgbClr val="1B1B1B"/>
                 </a:solidFill>
@@ -9041,17 +9046,93 @@
                 <a:spcPct val="105000"/>
               </a:lnSpc>
               <a:spcAft>
-                <a:spcPts val="300"/>
-              </a:spcAft>
-            </a:pPr>
-            <a:r>
-              <a:rPr sz="1100" b="0">
+                <a:spcPts val="200"/>
+              </a:spcAft>
+            </a:pPr>
+            <a:r>
+              <a:rPr sz="1000" b="0">
                 <a:solidFill>
                   <a:srgbClr val="1B1B1B"/>
                 </a:solidFill>
                 <a:latin typeface="Calibri"/>
               </a:rPr>
               <a:t>[11] "Hardware implementation for O-RAN block floating point compression and decompression methods in 5G base station," Proc. ATC 2024. doi:10.1109/ATC63255.2024.10908174 (abstract)</a:t>
+            </a:r>
+          </a:p>
+          <a:p>
+            <a:pPr algn="l">
+              <a:lnSpc>
+                <a:spcPct val="105000"/>
+              </a:lnSpc>
+              <a:spcAft>
+                <a:spcPts val="200"/>
+              </a:spcAft>
+            </a:pPr>
+            <a:r>
+              <a:rPr sz="1000" b="0">
+                <a:solidFill>
+                  <a:srgbClr val="1B1B1B"/>
+                </a:solidFill>
+                <a:latin typeface="Calibri"/>
+              </a:rPr>
+              <a:t>[12] S. Yagi et al., "Deep learning-based nonlinear quantizer for fronthaul compression," Proc. OECC/PSC 2022. (abstract)</a:t>
+            </a:r>
+          </a:p>
+          <a:p>
+            <a:pPr algn="l">
+              <a:lnSpc>
+                <a:spcPct val="105000"/>
+              </a:lnSpc>
+              <a:spcAft>
+                <a:spcPts val="200"/>
+              </a:spcAft>
+            </a:pPr>
+            <a:r>
+              <a:rPr sz="1000" b="0">
+                <a:solidFill>
+                  <a:srgbClr val="1B1B1B"/>
+                </a:solidFill>
+                <a:latin typeface="Calibri"/>
+              </a:rPr>
+              <a:t>[13] R. Qiao, T. Jiang, W. Yu, "Learning-based fronthaul compression for uplink cloud radio access networks," Proc. IEEE ICC 2023, pp. 5928–5933. (abstract)</a:t>
+            </a:r>
+          </a:p>
+          <a:p>
+            <a:pPr algn="l">
+              <a:lnSpc>
+                <a:spcPct val="105000"/>
+              </a:lnSpc>
+              <a:spcAft>
+                <a:spcPts val="200"/>
+              </a:spcAft>
+            </a:pPr>
+            <a:r>
+              <a:rPr sz="1000" b="0">
+                <a:solidFill>
+                  <a:srgbClr val="1B1B1B"/>
+                </a:solidFill>
+                <a:latin typeface="Calibri"/>
+              </a:rPr>
+              <a:t>[14] R. Qiao, T. Jiang, W. Yu, "Meta-learning-based fronthaul compression for cloud radio access networks," arXiv:2403.09004, 2024; IEEE Trans. Wireless Commun., vol. 23, no. 9, 2024. (abstract)</a:t>
+            </a:r>
+          </a:p>
+          <a:p>
+            <a:pPr algn="l">
+              <a:lnSpc>
+                <a:spcPct val="105000"/>
+              </a:lnSpc>
+              <a:spcAft>
+                <a:spcPts val="200"/>
+              </a:spcAft>
+            </a:pPr>
+            <a:r>
+              <a:rPr sz="1000" b="0">
+                <a:solidFill>
+                  <a:srgbClr val="1B1B1B"/>
+                </a:solidFill>
+                <a:latin typeface="Calibri"/>
+              </a:rPr>
+              <a:t>[15] C.-K. Wen, W.-T. Shih, S. Jin, "Deep learning for massive MIMO CSI feedback," IEEE Wireless Commun. Lett., vol. 7, no. 5, pp. 748–751, 2018. (full text)</a:t>
             </a:r>
           </a:p>
         </p:txBody>
@@ -9315,188 +9396,264 @@
                 <a:spcPct val="105000"/>
               </a:lnSpc>
               <a:spcAft>
-                <a:spcPts val="300"/>
-              </a:spcAft>
-            </a:pPr>
-            <a:r>
-              <a:rPr sz="1100" b="0">
+                <a:spcPts val="200"/>
+              </a:spcAft>
+            </a:pPr>
+            <a:r>
+              <a:rPr sz="1000" b="0">
                 <a:solidFill>
                   <a:srgbClr val="1B1B1B"/>
                 </a:solidFill>
                 <a:latin typeface="Calibri"/>
               </a:rPr>
-              <a:t>[12] S. Yagi et al., "Deep learning-based nonlinear quantizer for fronthaul compression," Proc. OECC/PSC 2022. (abstract)</a:t>
-            </a:r>
-          </a:p>
-          <a:p>
-            <a:pPr algn="l">
-              <a:lnSpc>
-                <a:spcPct val="105000"/>
-              </a:lnSpc>
-              <a:spcAft>
-                <a:spcPts val="300"/>
-              </a:spcAft>
-            </a:pPr>
-            <a:r>
-              <a:rPr sz="1100" b="0">
+              <a:t>[16] F. W. Murti, S. Ali, G. Iosifidis, M. Latva-aho, "Learning-based orchestration for dynamic functional split and resource allocation in vRANs," Proc. EuCNC/6G Summit 2022. (full text)</a:t>
+            </a:r>
+          </a:p>
+          <a:p>
+            <a:pPr algn="l">
+              <a:lnSpc>
+                <a:spcPct val="105000"/>
+              </a:lnSpc>
+              <a:spcAft>
+                <a:spcPts val="200"/>
+              </a:spcAft>
+            </a:pPr>
+            <a:r>
+              <a:rPr sz="1000" b="0">
                 <a:solidFill>
                   <a:srgbClr val="1B1B1B"/>
                 </a:solidFill>
                 <a:latin typeface="Calibri"/>
               </a:rPr>
-              <a:t>[13] R. Qiao, T. Jiang, W. Yu, "Learning-based fronthaul compression for uplink cloud radio access networks," Proc. IEEE ICC 2023, pp. 5928–5933. (abstract)</a:t>
-            </a:r>
-          </a:p>
-          <a:p>
-            <a:pPr algn="l">
-              <a:lnSpc>
-                <a:spcPct val="105000"/>
-              </a:lnSpc>
-              <a:spcAft>
-                <a:spcPts val="300"/>
-              </a:spcAft>
-            </a:pPr>
-            <a:r>
-              <a:rPr sz="1100" b="0">
+              <a:t>[17] F. W. Murti, S. Ali, G. Iosifidis, M. Latva-aho, "Deep reinforcement learning for orchestrating cost-aware reconfigurations of vRANs," IEEE Trans. Netw. Service Manag., vol. 21, no. 1, pp. 200–216, 2024. doi:10.1109/TNSM.2023.3292713 (full text)</a:t>
+            </a:r>
+          </a:p>
+          <a:p>
+            <a:pPr algn="l">
+              <a:lnSpc>
+                <a:spcPct val="105000"/>
+              </a:lnSpc>
+              <a:spcAft>
+                <a:spcPts val="200"/>
+              </a:spcAft>
+            </a:pPr>
+            <a:r>
+              <a:rPr sz="1000" b="0">
                 <a:solidFill>
                   <a:srgbClr val="1B1B1B"/>
                 </a:solidFill>
                 <a:latin typeface="Calibri"/>
               </a:rPr>
-              <a:t>[14] R. Qiao, T. Jiang, W. Yu, "Meta-learning-based fronthaul compression for cloud radio access networks," arXiv:2403.09004, 2024; IEEE Trans. Wireless Commun., vol. 23, no. 9, 2024. (abstract)</a:t>
-            </a:r>
-          </a:p>
-          <a:p>
-            <a:pPr algn="l">
-              <a:lnSpc>
-                <a:spcPct val="105000"/>
-              </a:lnSpc>
-              <a:spcAft>
-                <a:spcPts val="300"/>
-              </a:spcAft>
-            </a:pPr>
-            <a:r>
-              <a:rPr sz="1100" b="0">
+              <a:t>[18] F. W. Murti, S. Ali, M. Latva-aho, "Constrained deep reinforcement based functional split optimization in virtualized RANs," arXiv:2106.00011, 2021. (abstract)</a:t>
+            </a:r>
+          </a:p>
+          <a:p>
+            <a:pPr algn="l">
+              <a:lnSpc>
+                <a:spcPct val="105000"/>
+              </a:lnSpc>
+              <a:spcAft>
+                <a:spcPts val="200"/>
+              </a:spcAft>
+            </a:pPr>
+            <a:r>
+              <a:rPr sz="1000" b="0">
                 <a:solidFill>
                   <a:srgbClr val="1B1B1B"/>
                 </a:solidFill>
                 <a:latin typeface="Calibri"/>
               </a:rPr>
-              <a:t>[15] C.-K. Wen, W.-T. Shih, S. Jin, "Deep learning for massive MIMO CSI feedback," IEEE Wireless Commun. Lett., vol. 7, no. 5, pp. 748–751, 2018. (full text)</a:t>
-            </a:r>
-          </a:p>
-          <a:p>
-            <a:pPr algn="l">
-              <a:lnSpc>
-                <a:spcPct val="105000"/>
-              </a:lnSpc>
-              <a:spcAft>
-                <a:spcPts val="300"/>
-              </a:spcAft>
-            </a:pPr>
-            <a:r>
-              <a:rPr sz="1100" b="0">
+              <a:t>[19] N. Halko, P.-G. Martinsson, J. A. Tropp, "Finding structure with randomness," SIAM Rev., vol. 53, no. 2, pp. 217–288, 2011. doi:10.1137/090771806 (full text)</a:t>
+            </a:r>
+          </a:p>
+          <a:p>
+            <a:pPr algn="l">
+              <a:lnSpc>
+                <a:spcPct val="105000"/>
+              </a:lnSpc>
+              <a:spcAft>
+                <a:spcPts val="200"/>
+              </a:spcAft>
+            </a:pPr>
+            <a:r>
+              <a:rPr sz="1000" b="0">
                 <a:solidFill>
                   <a:srgbClr val="1B1B1B"/>
                 </a:solidFill>
                 <a:latin typeface="Calibri"/>
               </a:rPr>
-              <a:t>[16] F. W. Murti, S. Ali, G. Iosifidis, M. Latva-aho, "Learning-based orchestration for dynamic functional split and resource allocation in vRANs," Proc. EuCNC/6G Summit 2022. (full text)</a:t>
-            </a:r>
-          </a:p>
-          <a:p>
-            <a:pPr algn="l">
-              <a:lnSpc>
-                <a:spcPct val="105000"/>
-              </a:lnSpc>
-              <a:spcAft>
-                <a:spcPts val="300"/>
-              </a:spcAft>
-            </a:pPr>
-            <a:r>
-              <a:rPr sz="1100" b="0">
+              <a:t>[20] J. A. Tropp, "Improved analysis of the subsampled randomized Hadamard transform," Adv. Adapt. Data Anal., vol. 3, no. 1–2, pp. 115–126, 2011. (full text, preprint)</a:t>
+            </a:r>
+          </a:p>
+          <a:p>
+            <a:pPr algn="l">
+              <a:lnSpc>
+                <a:spcPct val="105000"/>
+              </a:lnSpc>
+              <a:spcAft>
+                <a:spcPts val="200"/>
+              </a:spcAft>
+            </a:pPr>
+            <a:r>
+              <a:rPr sz="1000" b="0">
                 <a:solidFill>
                   <a:srgbClr val="1B1B1B"/>
                 </a:solidFill>
                 <a:latin typeface="Calibri"/>
               </a:rPr>
-              <a:t>[17] F. W. Murti, S. Ali, G. Iosifidis, M. Latva-aho, "Deep reinforcement learning for orchestrating cost-aware reconfigurations of vRANs," IEEE Trans. Netw. Service Manag., vol. 21, no. 1, pp. 200–216, 2024. doi:10.1109/TNSM.2023.3292713 (full text)</a:t>
-            </a:r>
-          </a:p>
-          <a:p>
-            <a:pPr algn="l">
-              <a:lnSpc>
-                <a:spcPct val="105000"/>
-              </a:lnSpc>
-              <a:spcAft>
-                <a:spcPts val="300"/>
-              </a:spcAft>
-            </a:pPr>
-            <a:r>
-              <a:rPr sz="1100" b="0">
+              <a:t>[21] Y. Shoham, A. Gersho, "Efficient bit allocation for an arbitrary set of quantizers," IEEE Trans. Acoust., Speech, Signal Process., vol. 36, no. 9, pp. 1445–1453, 1988. doi:10.1109/29.90373 (abstract)</a:t>
+            </a:r>
+          </a:p>
+          <a:p>
+            <a:pPr algn="l">
+              <a:lnSpc>
+                <a:spcPct val="105000"/>
+              </a:lnSpc>
+              <a:spcAft>
+                <a:spcPts val="200"/>
+              </a:spcAft>
+            </a:pPr>
+            <a:r>
+              <a:rPr sz="1000" b="0">
                 <a:solidFill>
                   <a:srgbClr val="1B1B1B"/>
                 </a:solidFill>
                 <a:latin typeface="Calibri"/>
               </a:rPr>
-              <a:t>[18] F. W. Murti, S. Ali, M. Latva-aho, "Constrained deep reinforcement based functional split optimization in virtualized RANs," arXiv:2106.00011, 2021. (abstract)</a:t>
-            </a:r>
-          </a:p>
-          <a:p>
-            <a:pPr algn="l">
-              <a:lnSpc>
-                <a:spcPct val="105000"/>
-              </a:lnSpc>
-              <a:spcAft>
-                <a:spcPts val="300"/>
-              </a:spcAft>
-            </a:pPr>
-            <a:r>
-              <a:rPr sz="1100" b="0">
+              <a:t>[22] Aswathylakshmi P, R. K. Ganti, "Fronthaul compression for uplink massive MIMO using matrix decomposition," Proc. IEEE WCNC 2022, pp. 2524–2529. doi:10.1109/WCNC51071.2022.9771783 (full text)</a:t>
+            </a:r>
+          </a:p>
+          <a:p>
+            <a:pPr algn="l">
+              <a:lnSpc>
+                <a:spcPct val="105000"/>
+              </a:lnSpc>
+              <a:spcAft>
+                <a:spcPts val="200"/>
+              </a:spcAft>
+            </a:pPr>
+            <a:r>
+              <a:rPr sz="1000" b="0">
                 <a:solidFill>
                   <a:srgbClr val="1B1B1B"/>
                 </a:solidFill>
                 <a:latin typeface="Calibri"/>
               </a:rPr>
-              <a:t>[19] N. Halko, P.-G. Martinsson, J. A. Tropp, "Finding structure with randomness," SIAM Rev., vol. 53, no. 2, pp. 217–288, 2011. doi:10.1137/090771806 (full text)</a:t>
-            </a:r>
-          </a:p>
-          <a:p>
-            <a:pPr algn="l">
-              <a:lnSpc>
-                <a:spcPct val="105000"/>
-              </a:lnSpc>
-              <a:spcAft>
-                <a:spcPts val="300"/>
-              </a:spcAft>
-            </a:pPr>
-            <a:r>
-              <a:rPr sz="1100" b="0">
+              <a:t>[23] F. Wiffen, W. H. Chin, A. Doufexi, "Distributed dimension reduction for distributed massive MIMO C-RAN with finite fronthaul capacity," Proc. Asilomar 2021, pp. 1228–1236. doi:10.1109/IEEECONF53345.2021.9723180 (full text)</a:t>
+            </a:r>
+          </a:p>
+          <a:p>
+            <a:pPr algn="l">
+              <a:lnSpc>
+                <a:spcPct val="105000"/>
+              </a:lnSpc>
+              <a:spcAft>
+                <a:spcPts val="200"/>
+              </a:spcAft>
+            </a:pPr>
+            <a:r>
+              <a:rPr sz="1000" b="0">
                 <a:solidFill>
                   <a:srgbClr val="1B1B1B"/>
                 </a:solidFill>
                 <a:latin typeface="Calibri"/>
               </a:rPr>
-              <a:t>[20] J. A. Tropp, "Improved analysis of the subsampled randomized Hadamard transform," Adv. Adapt. Data Anal., vol. 3, no. 1–2, pp. 115–126, 2011. (full text, preprint)</a:t>
-            </a:r>
-          </a:p>
-          <a:p>
-            <a:pPr algn="l">
-              <a:lnSpc>
-                <a:spcPct val="105000"/>
-              </a:lnSpc>
-              <a:spcAft>
-                <a:spcPts val="300"/>
-              </a:spcAft>
-            </a:pPr>
-            <a:r>
-              <a:rPr sz="1100" b="0">
+              <a:t>[24] L. Li et al., "Enabling flexible link capacity for eCPRI-based fronthaul with load-adaptive quantization resolution," IEEE Access, vol. 7, pp. 102174–102185, 2019. doi:10.1109/ACCESS.2019.2930214 (full text)</a:t>
+            </a:r>
+          </a:p>
+          <a:p>
+            <a:pPr algn="l">
+              <a:lnSpc>
+                <a:spcPct val="105000"/>
+              </a:lnSpc>
+              <a:spcAft>
+                <a:spcPts val="200"/>
+              </a:spcAft>
+            </a:pPr>
+            <a:r>
+              <a:rPr sz="1000" b="0">
                 <a:solidFill>
                   <a:srgbClr val="1B1B1B"/>
                 </a:solidFill>
                 <a:latin typeface="Calibri"/>
               </a:rPr>
-              <a:t>[21] Y. Shoham, A. Gersho, "Efficient bit allocation for an arbitrary set of quantizers," IEEE Trans. Acoust., Speech, Signal Process., vol. 36, no. 9, pp. 1445–1453, 1988. doi:10.1109/29.90373 (abstract)</a:t>
+              <a:t>[25] I. Kanno et al., "Adaptive bit allocation for SVD based hybrid processing of uplink cell-free massive MIMO under limited fronthaul capacity," Proc. IEEE VTC2023-Spring. doi:10.1109/VTC2023-Spring57618.2023.10201009 (abstract)</a:t>
+            </a:r>
+          </a:p>
+          <a:p>
+            <a:pPr algn="l">
+              <a:lnSpc>
+                <a:spcPct val="105000"/>
+              </a:lnSpc>
+              <a:spcAft>
+                <a:spcPts val="200"/>
+              </a:spcAft>
+            </a:pPr>
+            <a:r>
+              <a:rPr sz="1000" b="0">
+                <a:solidFill>
+                  <a:srgbClr val="1B1B1B"/>
+                </a:solidFill>
+                <a:latin typeface="Calibri"/>
+              </a:rPr>
+              <a:t>[26] L. Liu, R. Zhang, "Optimized uplink transmission in multi-antenna C-RAN with spatial compression and forward," IEEE Trans. Signal Process., vol. 63, no. 19, pp. 5083–5095, 2015. (abstract)</a:t>
+            </a:r>
+          </a:p>
+          <a:p>
+            <a:pPr algn="l">
+              <a:lnSpc>
+                <a:spcPct val="105000"/>
+              </a:lnSpc>
+              <a:spcAft>
+                <a:spcPts val="200"/>
+              </a:spcAft>
+            </a:pPr>
+            <a:r>
+              <a:rPr sz="1000" b="0">
+                <a:solidFill>
+                  <a:srgbClr val="1B1B1B"/>
+                </a:solidFill>
+                <a:latin typeface="Calibri"/>
+              </a:rPr>
+              <a:t>[27] A. Martínez Alba, W. Kellerer, "Dynamic functional split adaptation in next-generation radio access networks," IEEE Trans. Netw. Service Manag., vol. 19, no. 3, pp. 3239–3263, 2022. (abstract)</a:t>
+            </a:r>
+          </a:p>
+          <a:p>
+            <a:pPr algn="l">
+              <a:lnSpc>
+                <a:spcPct val="105000"/>
+              </a:lnSpc>
+              <a:spcAft>
+                <a:spcPts val="200"/>
+              </a:spcAft>
+            </a:pPr>
+            <a:r>
+              <a:rPr sz="1000" b="0">
+                <a:solidFill>
+                  <a:srgbClr val="1B1B1B"/>
+                </a:solidFill>
+                <a:latin typeface="Calibri"/>
+              </a:rPr>
+              <a:t>[28] L. Wang, S. Zhou, "On the fronthaul statistical multiplexing gain," IEEE Commun. Lett., vol. 21, no. 5, pp. 1099–1102, 2017. (abstract)</a:t>
+            </a:r>
+          </a:p>
+          <a:p>
+            <a:pPr algn="l">
+              <a:lnSpc>
+                <a:spcPct val="105000"/>
+              </a:lnSpc>
+              <a:spcAft>
+                <a:spcPts val="200"/>
+              </a:spcAft>
+            </a:pPr>
+            <a:r>
+              <a:rPr sz="1000" b="0">
+                <a:solidFill>
+                  <a:srgbClr val="1B1B1B"/>
+                </a:solidFill>
+                <a:latin typeface="Calibri"/>
+              </a:rPr>
+              <a:t>[29] 3GPP TR 38.901 V19.4.0, "Study on channel model for frequencies from 0.5 to 100 GHz," cl. 7.7.2–7.7.5 (TDL-A, delay scaling, correlation extension).</a:t>
             </a:r>
           </a:p>
         </p:txBody>
@@ -13867,8 +14024,8 @@
           <p:nvPr/>
         </p:nvGraphicFramePr>
         <p:xfrm>
-          <a:off x="365760" y="1371600"/>
-          <a:ext cx="11430000" cy="4023360"/>
+          <a:off x="365760" y="1325880"/>
+          <a:ext cx="11430000" cy="4206240"/>
         </p:xfrm>
         <a:graphic>
           <a:graphicData uri="http://schemas.openxmlformats.org/drawingml/2006/table">
@@ -13877,12 +14034,12 @@
                 <a:tableStyleId>{5C22544A-7EE6-4342-B048-85BDC9FD1C3A}</a:tableStyleId>
               </a:tblPr>
               <a:tblGrid>
-                <a:gridCol w="1828800"/>
-                <a:gridCol w="3017520"/>
-                <a:gridCol w="3474720"/>
-                <a:gridCol w="3108960"/>
+                <a:gridCol w="1645920"/>
+                <a:gridCol w="2926080"/>
+                <a:gridCol w="3291840"/>
+                <a:gridCol w="3566160"/>
               </a:tblGrid>
-              <a:tr h="574765">
+              <a:tr h="525780">
                 <a:tc>
                   <a:txBody>
                     <a:bodyPr wrap="square"/>
@@ -13890,7 +14047,7 @@
                     <a:p>
                       <a:pPr algn="l"/>
                       <a:r>
-                        <a:rPr sz="1050" b="1">
+                        <a:rPr sz="1000" b="1">
                           <a:solidFill>
                             <a:srgbClr val="FFFFFF"/>
                           </a:solidFill>
@@ -13913,7 +14070,7 @@
                     <a:p>
                       <a:pPr algn="ctr"/>
                       <a:r>
-                        <a:rPr sz="1050" b="1">
+                        <a:rPr sz="1000" b="1">
                           <a:solidFill>
                             <a:srgbClr val="FFFFFF"/>
                           </a:solidFill>
@@ -13936,7 +14093,7 @@
                     <a:p>
                       <a:pPr algn="ctr"/>
                       <a:r>
-                        <a:rPr sz="1050" b="1">
+                        <a:rPr sz="1000" b="1">
                           <a:solidFill>
                             <a:srgbClr val="FFFFFF"/>
                           </a:solidFill>
@@ -13959,7 +14116,7 @@
                     <a:p>
                       <a:pPr algn="ctr"/>
                       <a:r>
-                        <a:rPr sz="1050" b="1">
+                        <a:rPr sz="1000" b="1">
                           <a:solidFill>
                             <a:srgbClr val="FFFFFF"/>
                           </a:solidFill>
@@ -13976,7 +14133,7 @@
                   </a:tcPr>
                 </a:tc>
               </a:tr>
-              <a:tr h="574765">
+              <a:tr h="525780">
                 <a:tc>
                   <a:txBody>
                     <a:bodyPr wrap="square"/>
@@ -13984,7 +14141,7 @@
                     <a:p>
                       <a:pPr algn="l"/>
                       <a:r>
-                        <a:rPr sz="1050">
+                        <a:rPr sz="1000">
                           <a:solidFill>
                             <a:srgbClr val="1B1B1B"/>
                           </a:solidFill>
@@ -14007,7 +14164,7 @@
                     <a:p>
                       <a:pPr algn="ctr"/>
                       <a:r>
-                        <a:rPr sz="1050">
+                        <a:rPr sz="1000">
                           <a:solidFill>
                             <a:srgbClr val="1B1B1B"/>
                           </a:solidFill>
@@ -14030,7 +14187,7 @@
                     <a:p>
                       <a:pPr algn="ctr"/>
                       <a:r>
-                        <a:rPr sz="1050">
+                        <a:rPr sz="1000">
                           <a:solidFill>
                             <a:srgbClr val="1B1B1B"/>
                           </a:solidFill>
@@ -14053,7 +14210,7 @@
                     <a:p>
                       <a:pPr algn="ctr"/>
                       <a:r>
-                        <a:rPr sz="1050">
+                        <a:rPr sz="1000">
                           <a:solidFill>
                             <a:srgbClr val="1B1B1B"/>
                           </a:solidFill>
@@ -14070,7 +14227,7 @@
                   </a:tcPr>
                 </a:tc>
               </a:tr>
-              <a:tr h="574765">
+              <a:tr h="525780">
                 <a:tc>
                   <a:txBody>
                     <a:bodyPr wrap="square"/>
@@ -14078,7 +14235,7 @@
                     <a:p>
                       <a:pPr algn="l"/>
                       <a:r>
-                        <a:rPr sz="1050">
+                        <a:rPr sz="1000">
                           <a:solidFill>
                             <a:srgbClr val="1B1B1B"/>
                           </a:solidFill>
@@ -14101,7 +14258,7 @@
                     <a:p>
                       <a:pPr algn="ctr"/>
                       <a:r>
-                        <a:rPr sz="1050">
+                        <a:rPr sz="1000">
                           <a:solidFill>
                             <a:srgbClr val="1B1B1B"/>
                           </a:solidFill>
@@ -14124,7 +14281,7 @@
                     <a:p>
                       <a:pPr algn="ctr"/>
                       <a:r>
-                        <a:rPr sz="1050">
+                        <a:rPr sz="1000">
                           <a:solidFill>
                             <a:srgbClr val="1B1B1B"/>
                           </a:solidFill>
@@ -14147,7 +14304,7 @@
                     <a:p>
                       <a:pPr algn="ctr"/>
                       <a:r>
-                        <a:rPr sz="1050">
+                        <a:rPr sz="1000">
                           <a:solidFill>
                             <a:srgbClr val="1B1B1B"/>
                           </a:solidFill>
@@ -14164,7 +14321,7 @@
                   </a:tcPr>
                 </a:tc>
               </a:tr>
-              <a:tr h="574765">
+              <a:tr h="525780">
                 <a:tc>
                   <a:txBody>
                     <a:bodyPr wrap="square"/>
@@ -14172,7 +14329,7 @@
                     <a:p>
                       <a:pPr algn="l"/>
                       <a:r>
-                        <a:rPr sz="1050">
+                        <a:rPr sz="1000">
                           <a:solidFill>
                             <a:srgbClr val="1B1B1B"/>
                           </a:solidFill>
@@ -14195,7 +14352,7 @@
                     <a:p>
                       <a:pPr algn="ctr"/>
                       <a:r>
-                        <a:rPr sz="1050">
+                        <a:rPr sz="1000">
                           <a:solidFill>
                             <a:srgbClr val="1B1B1B"/>
                           </a:solidFill>
@@ -14218,7 +14375,7 @@
                     <a:p>
                       <a:pPr algn="ctr"/>
                       <a:r>
-                        <a:rPr sz="1050">
+                        <a:rPr sz="1000">
                           <a:solidFill>
                             <a:srgbClr val="1B1B1B"/>
                           </a:solidFill>
@@ -14241,13 +14398,13 @@
                     <a:p>
                       <a:pPr algn="ctr"/>
                       <a:r>
-                        <a:rPr sz="1050">
+                        <a:rPr sz="1000">
                           <a:solidFill>
                             <a:srgbClr val="1B1B1B"/>
                           </a:solidFill>
                           <a:latin typeface="Calibri"/>
                         </a:rPr>
-                        <a:t>closest template for Exp5 (per-cell operating point, common capacity); ours is UL I/Q with NMSE, no MAC</a:t>
+                        <a:t>template for Exp5 (per-cell operating point, common capacity); ours is UL I/Q with NMSE, no MAC</a:t>
                       </a:r>
                     </a:p>
                   </a:txBody>
@@ -14258,7 +14415,7 @@
                   </a:tcPr>
                 </a:tc>
               </a:tr>
-              <a:tr h="574765">
+              <a:tr h="525780">
                 <a:tc>
                   <a:txBody>
                     <a:bodyPr wrap="square"/>
@@ -14266,7 +14423,7 @@
                     <a:p>
                       <a:pPr algn="l"/>
                       <a:r>
-                        <a:rPr sz="1050">
+                        <a:rPr sz="1000">
                           <a:solidFill>
                             <a:srgbClr val="1B1B1B"/>
                           </a:solidFill>
@@ -14289,7 +14446,7 @@
                     <a:p>
                       <a:pPr algn="ctr"/>
                       <a:r>
-                        <a:rPr sz="1050">
+                        <a:rPr sz="1000">
                           <a:solidFill>
                             <a:srgbClr val="1B1B1B"/>
                           </a:solidFill>
@@ -14312,7 +14469,7 @@
                     <a:p>
                       <a:pPr algn="ctr"/>
                       <a:r>
-                        <a:rPr sz="1050">
+                        <a:rPr sz="1000">
                           <a:solidFill>
                             <a:srgbClr val="1B1B1B"/>
                           </a:solidFill>
@@ -14335,7 +14492,7 @@
                     <a:p>
                       <a:pPr algn="ctr"/>
                       <a:r>
-                        <a:rPr sz="1050">
+                        <a:rPr sz="1000">
                           <a:solidFill>
                             <a:srgbClr val="1B1B1B"/>
                           </a:solidFill>
@@ -14352,7 +14509,7 @@
                   </a:tcPr>
                 </a:tc>
               </a:tr>
-              <a:tr h="574765">
+              <a:tr h="525780">
                 <a:tc>
                   <a:txBody>
                     <a:bodyPr wrap="square"/>
@@ -14360,13 +14517,13 @@
                     <a:p>
                       <a:pPr algn="l"/>
                       <a:r>
-                        <a:rPr sz="1050">
+                        <a:rPr sz="1000">
                           <a:solidFill>
                             <a:srgbClr val="1B1B1B"/>
                           </a:solidFill>
                           <a:latin typeface="Calibri"/>
                         </a:rPr>
-                        <a:t>Learning-based split orchestration</a:t>
+                        <a:t>Closest single-link prior art</a:t>
                       </a:r>
                     </a:p>
                   </a:txBody>
@@ -14383,13 +14540,13 @@
                     <a:p>
                       <a:pPr algn="ctr"/>
                       <a:r>
-                        <a:rPr sz="1050">
+                        <a:rPr sz="1000">
                           <a:solidFill>
                             <a:srgbClr val="1B1B1B"/>
                           </a:solidFill>
                           <a:latin typeface="Calibri"/>
                         </a:rPr>
-                        <a:t>Murti et al., EuCNC 2022 [16]; IEEE TNSM 2024 [17]</a:t>
+                        <a:t>Aswathylakshmi–Ganti, WCNC 2022 [22]; Li et al., IEEE Access 2019 [24]; Kanno et al., VTC 2023 [25]</a:t>
                       </a:r>
                     </a:p>
                   </a:txBody>
@@ -14406,13 +14563,13 @@
                     <a:p>
                       <a:pPr algn="ctr"/>
                       <a:r>
-                        <a:rPr sz="1050">
+                        <a:rPr sz="1000">
                           <a:solidFill>
                             <a:srgbClr val="1B1B1B"/>
                           </a:solidFill>
                           <a:latin typeface="Calibri"/>
                         </a:rPr>
-                        <a:t>DQN / D3QN over minutes-scale demand traces; cost model from testbed; up to 59–69 % cost saving vs static</a:t>
+                        <a:t>64-ant. TDL-A delay-domain low rank via blind deconvolution; bit-width vs load/SINR on one eCPRI link; SVD streams + bits per stream at one AP</a:t>
                       </a:r>
                     </a:p>
                   </a:txBody>
@@ -14429,13 +14586,13 @@
                     <a:p>
                       <a:pPr algn="ctr"/>
                       <a:r>
-                        <a:rPr sz="1050">
+                        <a:rPr sz="1000">
                           <a:solidFill>
                             <a:srgbClr val="1B1B1B"/>
                           </a:solidFill>
                           <a:latin typeface="Calibri"/>
                         </a:rPr>
-                        <a:t>justifies adaptive split as a topic; RL not warranted here because our rate model is closed-form per symbol</a:t>
+                        <a:t>CSEE's structure, but data symbols removed first — hence CSEE needs reference symbols; allocator extends [24][25] to many RUs</a:t>
                       </a:r>
                     </a:p>
                   </a:txBody>
@@ -14446,7 +14603,7 @@
                   </a:tcPr>
                 </a:tc>
               </a:tr>
-              <a:tr h="574770">
+              <a:tr h="525780">
                 <a:tc>
                   <a:txBody>
                     <a:bodyPr wrap="square"/>
@@ -14454,13 +14611,13 @@
                     <a:p>
                       <a:pPr algn="l"/>
                       <a:r>
-                        <a:rPr sz="1050">
+                        <a:rPr sz="1000">
                           <a:solidFill>
                             <a:srgbClr val="1B1B1B"/>
                           </a:solidFill>
                           <a:latin typeface="Calibri"/>
                         </a:rPr>
-                        <a:t>Numerical foundations</a:t>
+                        <a:t>Learning-based split orchestration</a:t>
                       </a:r>
                     </a:p>
                   </a:txBody>
@@ -14477,13 +14634,13 @@
                     <a:p>
                       <a:pPr algn="ctr"/>
                       <a:r>
-                        <a:rPr sz="1050">
+                        <a:rPr sz="1000">
                           <a:solidFill>
                             <a:srgbClr val="1B1B1B"/>
                           </a:solidFill>
                           <a:latin typeface="Calibri"/>
                         </a:rPr>
-                        <a:t>Halko–Martinsson–Tropp, SIAM Rev. 2011 [19]; Tropp 2011 [20]; Shoham–Gersho 1988 [21]</a:t>
+                        <a:t>Murti et al., EuCNC 2022 [16]; IEEE TNSM 2024 [17]</a:t>
                       </a:r>
                     </a:p>
                   </a:txBody>
@@ -14500,13 +14657,13 @@
                     <a:p>
                       <a:pPr algn="ctr"/>
                       <a:r>
-                        <a:rPr sz="1050">
+                        <a:rPr sz="1000">
                           <a:solidFill>
                             <a:srgbClr val="1B1B1B"/>
                           </a:solidFill>
                           <a:latin typeface="Calibri"/>
                         </a:rPr>
-                        <a:t>randomised range finder + Frobenius bound; SRHT subspace embedding; λ-sweep / convex-hull bit allocation</a:t>
+                        <a:t>DQN / D3QN over minutes-scale demand traces; cost model from testbed; up to 59–69 % cost saving vs static</a:t>
                       </a:r>
                     </a:p>
                   </a:txBody>
@@ -14523,7 +14680,101 @@
                     <a:p>
                       <a:pPr algn="ctr"/>
                       <a:r>
-                        <a:rPr sz="1050">
+                        <a:rPr sz="1000">
+                          <a:solidFill>
+                            <a:srgbClr val="1B1B1B"/>
+                          </a:solidFill>
+                          <a:latin typeface="Calibri"/>
+                        </a:rPr>
+                        <a:t>justifies adaptive split as a topic; RL not warranted here because our rate model is closed-form per symbol</a:t>
+                      </a:r>
+                    </a:p>
+                  </a:txBody>
+                  <a:tcPr marL="45720" marR="45720" marT="18288" marB="18288">
+                    <a:solidFill>
+                      <a:srgbClr val="F4F6F8"/>
+                    </a:solidFill>
+                  </a:tcPr>
+                </a:tc>
+              </a:tr>
+              <a:tr h="525780">
+                <a:tc>
+                  <a:txBody>
+                    <a:bodyPr wrap="square"/>
+                    <a:lstStyle/>
+                    <a:p>
+                      <a:pPr algn="l"/>
+                      <a:r>
+                        <a:rPr sz="1000">
+                          <a:solidFill>
+                            <a:srgbClr val="1B1B1B"/>
+                          </a:solidFill>
+                          <a:latin typeface="Calibri"/>
+                        </a:rPr>
+                        <a:t>Numerical foundations</a:t>
+                      </a:r>
+                    </a:p>
+                  </a:txBody>
+                  <a:tcPr marL="45720" marR="45720" marT="18288" marB="18288">
+                    <a:solidFill>
+                      <a:srgbClr val="FFFFFF"/>
+                    </a:solidFill>
+                  </a:tcPr>
+                </a:tc>
+                <a:tc>
+                  <a:txBody>
+                    <a:bodyPr wrap="square"/>
+                    <a:lstStyle/>
+                    <a:p>
+                      <a:pPr algn="ctr"/>
+                      <a:r>
+                        <a:rPr sz="1000">
+                          <a:solidFill>
+                            <a:srgbClr val="1B1B1B"/>
+                          </a:solidFill>
+                          <a:latin typeface="Calibri"/>
+                        </a:rPr>
+                        <a:t>Halko–Martinsson–Tropp, SIAM Rev. 2011 [19]; Tropp 2011 [20]; Shoham–Gersho 1988 [21]</a:t>
+                      </a:r>
+                    </a:p>
+                  </a:txBody>
+                  <a:tcPr marL="45720" marR="45720" marT="18288" marB="18288">
+                    <a:solidFill>
+                      <a:srgbClr val="FFFFFF"/>
+                    </a:solidFill>
+                  </a:tcPr>
+                </a:tc>
+                <a:tc>
+                  <a:txBody>
+                    <a:bodyPr wrap="square"/>
+                    <a:lstStyle/>
+                    <a:p>
+                      <a:pPr algn="ctr"/>
+                      <a:r>
+                        <a:rPr sz="1000">
+                          <a:solidFill>
+                            <a:srgbClr val="1B1B1B"/>
+                          </a:solidFill>
+                          <a:latin typeface="Calibri"/>
+                        </a:rPr>
+                        <a:t>randomised range finder + Frobenius bound; SRHT subspace embedding; λ-sweep / convex-hull bit allocation</a:t>
+                      </a:r>
+                    </a:p>
+                  </a:txBody>
+                  <a:tcPr marL="45720" marR="45720" marT="18288" marB="18288">
+                    <a:solidFill>
+                      <a:srgbClr val="FFFFFF"/>
+                    </a:solidFill>
+                  </a:tcPr>
+                </a:tc>
+                <a:tc>
+                  <a:txBody>
+                    <a:bodyPr wrap="square"/>
+                    <a:lstStyle/>
+                    <a:p>
+                      <a:pPr algn="ctr"/>
+                      <a:r>
+                        <a:rPr sz="1000">
                           <a:solidFill>
                             <a:srgbClr val="1B1B1B"/>
                           </a:solidFill>
@@ -14535,7 +14786,7 @@
                   </a:txBody>
                   <a:tcPr marL="45720" marR="45720" marT="18288" marB="18288">
                     <a:solidFill>
-                      <a:srgbClr val="F4F6F8"/>
+                      <a:srgbClr val="FFFFFF"/>
                     </a:solidFill>
                   </a:tcPr>
                 </a:tc>
@@ -14627,7 +14878,7 @@
                 </a:solidFill>
                 <a:latin typeface="Calibri"/>
               </a:rPr>
-              <a:t>Gap addressed: uplink I/Q encoders with a closed-form per-symbol rate-distortion predictor, driving a shared-capacity allocation across RUs, evaluated with a metric that separates signal loss from removed noise.</a:t>
+              <a:t>Gap addressed: prior art adapts bits or streams on one link [22][24][25]; here a closed-form per-symbol predictor drives allocation across RUs sharing one link, with a metric separating signal loss from removed noise.</a:t>
             </a:r>
           </a:p>
         </p:txBody>

</xml_diff>